<commit_message>
Fix overlapping shapes and enforce exact symmetry across all three slides
Co-Authored-By: Claude Sonnet 5 <noreply@anthropic.com>
Claude-Session: https://claude.ai/code/session_018Bg71BX6us34ZYpqiy24Sa
</commit_message>
<xml_diff>
--- a/Michigan_Use_Case_Slides.pptx
+++ b/Michigan_Use_Case_Slides.pptx
@@ -14506,7 +14506,7 @@
         <p:spPr>
           <a:xfrm>
             <a:off x="457200" y="1508760"/>
-            <a:ext cx="5394960" cy="3931920"/>
+            <a:ext cx="5410047" cy="3931920"/>
           </a:xfrm>
           <a:prstGeom prst="roundRect">
             <a:avLst>
@@ -14663,8 +14663,8 @@
         </p:nvSpPr>
         <p:spPr>
           <a:xfrm>
-            <a:off x="6309360" y="1508760"/>
-            <a:ext cx="5394960" cy="3931920"/>
+            <a:off x="6324447" y="1508760"/>
+            <a:ext cx="5410047" cy="3931920"/>
           </a:xfrm>
           <a:prstGeom prst="roundRect">
             <a:avLst>
@@ -15048,318 +15048,14 @@
       </p:sp>
       <p:sp>
         <p:nvSpPr>
-          <p:cNvPr id="4" name="Chevron 3"/>
-          <p:cNvSpPr/>
-          <p:nvPr/>
-        </p:nvSpPr>
-        <p:spPr>
-          <a:xfrm>
-            <a:off x="2377440" y="2834640"/>
-            <a:ext cx="1600200" cy="1005840"/>
-          </a:xfrm>
-          <a:prstGeom prst="chevron">
-            <a:avLst>
-              <a:gd name="adj" fmla="val 25000"/>
-            </a:avLst>
-          </a:prstGeom>
-          <a:solidFill>
-            <a:srgbClr val="002856"/>
-          </a:solidFill>
-          <a:ln w="19050">
-            <a:solidFill>
-              <a:srgbClr val="FFFFFF"/>
-            </a:solidFill>
-          </a:ln>
-        </p:spPr>
-        <p:style>
-          <a:lnRef idx="1">
-            <a:schemeClr val="accent1"/>
-          </a:lnRef>
-          <a:fillRef idx="3">
-            <a:schemeClr val="accent1"/>
-          </a:fillRef>
-          <a:effectRef idx="2">
-            <a:schemeClr val="accent1"/>
-          </a:effectRef>
-          <a:fontRef idx="minor">
-            <a:schemeClr val="lt1"/>
-          </a:fontRef>
-        </p:style>
-        <p:txBody>
-          <a:bodyPr rtlCol="0" anchor="ctr" wrap="square" lIns="137160" rIns="320040"/>
-          <a:lstStyle/>
-          <a:p>
-            <a:pPr algn="ctr"/>
-            <a:r>
-              <a:rPr b="1" sz="1300">
-                <a:solidFill>
-                  <a:srgbClr val="FFFFFF"/>
-                </a:solidFill>
-                <a:latin typeface="Arial"/>
-              </a:rPr>
-              <a:t>DTE Energy</a:t>
-            </a:r>
-          </a:p>
-          <a:p>
-            <a:pPr algn="ctr"/>
-            <a:r>
-              <a:rPr sz="900" i="1">
-                <a:solidFill>
-                  <a:srgbClr val="FFFFFF"/>
-                </a:solidFill>
-                <a:latin typeface="Arial"/>
-              </a:rPr>
-              <a:t>Owns Assets</a:t>
-            </a:r>
-          </a:p>
-        </p:txBody>
-      </p:sp>
-      <p:sp>
-        <p:nvSpPr>
-          <p:cNvPr id="5" name="Chevron 4"/>
-          <p:cNvSpPr/>
-          <p:nvPr/>
-        </p:nvSpPr>
-        <p:spPr>
-          <a:xfrm>
-            <a:off x="3657600" y="2834640"/>
-            <a:ext cx="1600200" cy="1005840"/>
-          </a:xfrm>
-          <a:prstGeom prst="chevron">
-            <a:avLst>
-              <a:gd name="adj" fmla="val 25000"/>
-            </a:avLst>
-          </a:prstGeom>
-          <a:solidFill>
-            <a:srgbClr val="FF8200"/>
-          </a:solidFill>
-          <a:ln w="19050">
-            <a:solidFill>
-              <a:srgbClr val="FFFFFF"/>
-            </a:solidFill>
-          </a:ln>
-        </p:spPr>
-        <p:style>
-          <a:lnRef idx="1">
-            <a:schemeClr val="accent1"/>
-          </a:lnRef>
-          <a:fillRef idx="3">
-            <a:schemeClr val="accent1"/>
-          </a:fillRef>
-          <a:effectRef idx="2">
-            <a:schemeClr val="accent1"/>
-          </a:effectRef>
-          <a:fontRef idx="minor">
-            <a:schemeClr val="lt1"/>
-          </a:fontRef>
-        </p:style>
-        <p:txBody>
-          <a:bodyPr rtlCol="0" anchor="ctr" wrap="square" lIns="137160" rIns="320040"/>
-          <a:lstStyle/>
-          <a:p>
-            <a:pPr algn="ctr"/>
-            <a:r>
-              <a:rPr b="1" sz="1300">
-                <a:solidFill>
-                  <a:srgbClr val="FFFFFF"/>
-                </a:solidFill>
-                <a:latin typeface="Arial"/>
-              </a:rPr>
-              <a:t>APTIM</a:t>
-            </a:r>
-          </a:p>
-          <a:p>
-            <a:pPr algn="ctr"/>
-            <a:r>
-              <a:rPr sz="900" i="1">
-                <a:solidFill>
-                  <a:srgbClr val="FFFFFF"/>
-                </a:solidFill>
-                <a:latin typeface="Arial"/>
-              </a:rPr>
-              <a:t>Administers Program</a:t>
-            </a:r>
-          </a:p>
-        </p:txBody>
-      </p:sp>
-      <p:sp>
-        <p:nvSpPr>
-          <p:cNvPr id="6" name="Chevron 5"/>
-          <p:cNvSpPr/>
-          <p:nvPr/>
-        </p:nvSpPr>
-        <p:spPr>
-          <a:xfrm>
-            <a:off x="4937760" y="2834640"/>
-            <a:ext cx="1600200" cy="1005840"/>
-          </a:xfrm>
-          <a:prstGeom prst="chevron">
-            <a:avLst>
-              <a:gd name="adj" fmla="val 25000"/>
-            </a:avLst>
-          </a:prstGeom>
-          <a:solidFill>
-            <a:srgbClr val="3D7CC9"/>
-          </a:solidFill>
-          <a:ln w="19050">
-            <a:solidFill>
-              <a:srgbClr val="FFFFFF"/>
-            </a:solidFill>
-          </a:ln>
-        </p:spPr>
-        <p:style>
-          <a:lnRef idx="1">
-            <a:schemeClr val="accent1"/>
-          </a:lnRef>
-          <a:fillRef idx="3">
-            <a:schemeClr val="accent1"/>
-          </a:fillRef>
-          <a:effectRef idx="2">
-            <a:schemeClr val="accent1"/>
-          </a:effectRef>
-          <a:fontRef idx="minor">
-            <a:schemeClr val="lt1"/>
-          </a:fontRef>
-        </p:style>
-        <p:txBody>
-          <a:bodyPr rtlCol="0" anchor="ctr" wrap="square" lIns="137160" rIns="320040"/>
-          <a:lstStyle/>
-          <a:p>
-            <a:pPr algn="ctr"/>
-            <a:r>
-              <a:rPr b="1" sz="1300">
-                <a:solidFill>
-                  <a:srgbClr val="FFFFFF"/>
-                </a:solidFill>
-                <a:latin typeface="Arial"/>
-              </a:rPr>
-              <a:t>Certified Installers</a:t>
-            </a:r>
-          </a:p>
-        </p:txBody>
-      </p:sp>
-      <p:sp>
-        <p:nvSpPr>
-          <p:cNvPr id="7" name="Chevron 6"/>
-          <p:cNvSpPr/>
-          <p:nvPr/>
-        </p:nvSpPr>
-        <p:spPr>
-          <a:xfrm>
-            <a:off x="6217920" y="2834640"/>
-            <a:ext cx="1600200" cy="1005840"/>
-          </a:xfrm>
-          <a:prstGeom prst="chevron">
-            <a:avLst>
-              <a:gd name="adj" fmla="val 25000"/>
-            </a:avLst>
-          </a:prstGeom>
-          <a:solidFill>
-            <a:srgbClr val="00A19B"/>
-          </a:solidFill>
-          <a:ln w="19050">
-            <a:solidFill>
-              <a:srgbClr val="FFFFFF"/>
-            </a:solidFill>
-          </a:ln>
-        </p:spPr>
-        <p:style>
-          <a:lnRef idx="1">
-            <a:schemeClr val="accent1"/>
-          </a:lnRef>
-          <a:fillRef idx="3">
-            <a:schemeClr val="accent1"/>
-          </a:fillRef>
-          <a:effectRef idx="2">
-            <a:schemeClr val="accent1"/>
-          </a:effectRef>
-          <a:fontRef idx="minor">
-            <a:schemeClr val="lt1"/>
-          </a:fontRef>
-        </p:style>
-        <p:txBody>
-          <a:bodyPr rtlCol="0" anchor="ctr" wrap="square" lIns="137160" rIns="320040"/>
-          <a:lstStyle/>
-          <a:p>
-            <a:pPr algn="ctr"/>
-            <a:r>
-              <a:rPr b="1" sz="1300">
-                <a:solidFill>
-                  <a:srgbClr val="FFFFFF"/>
-                </a:solidFill>
-                <a:latin typeface="Arial"/>
-              </a:rPr>
-              <a:t>500 Qualified Homes</a:t>
-            </a:r>
-          </a:p>
-        </p:txBody>
-      </p:sp>
-      <p:sp>
-        <p:nvSpPr>
-          <p:cNvPr id="8" name="Chevron 7"/>
-          <p:cNvSpPr/>
-          <p:nvPr/>
-        </p:nvSpPr>
-        <p:spPr>
-          <a:xfrm>
-            <a:off x="7498080" y="2834640"/>
-            <a:ext cx="1600200" cy="1005840"/>
-          </a:xfrm>
-          <a:prstGeom prst="chevron">
-            <a:avLst>
-              <a:gd name="adj" fmla="val 25000"/>
-            </a:avLst>
-          </a:prstGeom>
-          <a:solidFill>
-            <a:srgbClr val="A32036"/>
-          </a:solidFill>
-          <a:ln w="19050">
-            <a:solidFill>
-              <a:srgbClr val="FFFFFF"/>
-            </a:solidFill>
-          </a:ln>
-        </p:spPr>
-        <p:style>
-          <a:lnRef idx="1">
-            <a:schemeClr val="accent1"/>
-          </a:lnRef>
-          <a:fillRef idx="3">
-            <a:schemeClr val="accent1"/>
-          </a:fillRef>
-          <a:effectRef idx="2">
-            <a:schemeClr val="accent1"/>
-          </a:effectRef>
-          <a:fontRef idx="minor">
-            <a:schemeClr val="lt1"/>
-          </a:fontRef>
-        </p:style>
-        <p:txBody>
-          <a:bodyPr rtlCol="0" anchor="ctr" wrap="square" lIns="137160" rIns="320040"/>
-          <a:lstStyle/>
-          <a:p>
-            <a:pPr algn="ctr"/>
-            <a:r>
-              <a:rPr b="1" sz="1300">
-                <a:solidFill>
-                  <a:srgbClr val="FFFFFF"/>
-                </a:solidFill>
-                <a:latin typeface="Arial"/>
-              </a:rPr>
-              <a:t>3 MW Solar + 7.5 MWh Storage</a:t>
-            </a:r>
-          </a:p>
-        </p:txBody>
-      </p:sp>
-      <p:sp>
-        <p:nvSpPr>
-          <p:cNvPr id="9" name="Rounded Rectangle 8"/>
+          <p:cNvPr id="4" name="Rounded Rectangle 3"/>
           <p:cNvSpPr/>
           <p:nvPr/>
         </p:nvSpPr>
         <p:spPr>
           <a:xfrm>
             <a:off x="365760" y="1417320"/>
-            <a:ext cx="2880360" cy="4480560"/>
+            <a:ext cx="2514600" cy="4480560"/>
           </a:xfrm>
           <a:prstGeom prst="roundRect">
             <a:avLst>
@@ -15395,25 +15091,26 @@
           </a:fontRef>
         </p:style>
         <p:txBody>
-          <a:bodyPr rtlCol="0" anchor="ctr" wrap="square" lIns="182880" tIns="182880" rIns="137160"/>
+          <a:bodyPr rtlCol="0" anchor="ctr" wrap="square" lIns="164592" tIns="164592" rIns="109728"/>
           <a:lstStyle/>
           <a:p>
             <a:pPr algn="ctr">
               <a:spcAft>
-                <a:spcPts val="800"/>
+                <a:spcPts val="700"/>
               </a:spcAft>
             </a:pPr>
             <a:r>
-              <a:rPr b="1" sz="1400">
+              <a:rPr b="1" sz="1300">
                 <a:solidFill>
                   <a:srgbClr val="002856"/>
                 </a:solidFill>
                 <a:latin typeface="Arial"/>
               </a:rPr>
-              <a:t>Participant Requirements</a:t>
-            </a:r>
-            <a:r>
-              <a:rPr b="1" sz="1200">
+              <a:t>Participant
+Requirements</a:t>
+            </a:r>
+            <a:r>
+              <a:rPr b="1" sz="1100">
                 <a:solidFill>
                   <a:srgbClr val="FF8200"/>
                 </a:solidFill>
@@ -15422,7 +15119,7 @@
               <a:t>•  </a:t>
             </a:r>
             <a:r>
-              <a:rPr sz="1200">
+              <a:rPr sz="1100">
                 <a:solidFill>
                   <a:srgbClr val="404040"/>
                 </a:solidFill>
@@ -15434,11 +15131,11 @@
           <a:p>
             <a:pPr>
               <a:spcAft>
-                <a:spcPts val="800"/>
+                <a:spcPts val="700"/>
               </a:spcAft>
             </a:pPr>
             <a:r>
-              <a:rPr b="1" sz="1200">
+              <a:rPr b="1" sz="1100">
                 <a:solidFill>
                   <a:srgbClr val="FF8200"/>
                 </a:solidFill>
@@ -15447,7 +15144,7 @@
               <a:t>•  </a:t>
             </a:r>
             <a:r>
-              <a:rPr sz="1200">
+              <a:rPr sz="1100">
                 <a:solidFill>
                   <a:srgbClr val="404040"/>
                 </a:solidFill>
@@ -15459,11 +15156,11 @@
           <a:p>
             <a:pPr>
               <a:spcAft>
-                <a:spcPts val="800"/>
+                <a:spcPts val="700"/>
               </a:spcAft>
             </a:pPr>
             <a:r>
-              <a:rPr b="1" sz="1200">
+              <a:rPr b="1" sz="1100">
                 <a:solidFill>
                   <a:srgbClr val="FF8200"/>
                 </a:solidFill>
@@ -15472,7 +15169,7 @@
               <a:t>•  </a:t>
             </a:r>
             <a:r>
-              <a:rPr sz="1200">
+              <a:rPr sz="1100">
                 <a:solidFill>
                   <a:srgbClr val="404040"/>
                 </a:solidFill>
@@ -15484,11 +15181,11 @@
           <a:p>
             <a:pPr>
               <a:spcAft>
-                <a:spcPts val="800"/>
+                <a:spcPts val="700"/>
               </a:spcAft>
             </a:pPr>
             <a:r>
-              <a:rPr b="1" sz="1200">
+              <a:rPr b="1" sz="1100">
                 <a:solidFill>
                   <a:srgbClr val="FF8200"/>
                 </a:solidFill>
@@ -15497,7 +15194,7 @@
               <a:t>•  </a:t>
             </a:r>
             <a:r>
-              <a:rPr sz="1200">
+              <a:rPr sz="1100">
                 <a:solidFill>
                   <a:srgbClr val="404040"/>
                 </a:solidFill>
@@ -15509,11 +15206,11 @@
           <a:p>
             <a:pPr>
               <a:spcAft>
-                <a:spcPts val="800"/>
+                <a:spcPts val="700"/>
               </a:spcAft>
             </a:pPr>
             <a:r>
-              <a:rPr b="1" sz="1200">
+              <a:rPr b="1" sz="1100">
                 <a:solidFill>
                   <a:srgbClr val="FF8200"/>
                 </a:solidFill>
@@ -15522,7 +15219,7 @@
               <a:t>•  </a:t>
             </a:r>
             <a:r>
-              <a:rPr sz="1200">
+              <a:rPr sz="1100">
                 <a:solidFill>
                   <a:srgbClr val="404040"/>
                 </a:solidFill>
@@ -15534,11 +15231,11 @@
           <a:p>
             <a:pPr>
               <a:spcAft>
-                <a:spcPts val="800"/>
+                <a:spcPts val="700"/>
               </a:spcAft>
             </a:pPr>
             <a:r>
-              <a:rPr b="1" sz="1200">
+              <a:rPr b="1" sz="1100">
                 <a:solidFill>
                   <a:srgbClr val="FF8200"/>
                 </a:solidFill>
@@ -15547,7 +15244,7 @@
               <a:t>•  </a:t>
             </a:r>
             <a:r>
-              <a:rPr sz="1200">
+              <a:rPr sz="1100">
                 <a:solidFill>
                   <a:srgbClr val="404040"/>
                 </a:solidFill>
@@ -15560,14 +15257,14 @@
       </p:sp>
       <p:sp>
         <p:nvSpPr>
-          <p:cNvPr id="10" name="Rounded Rectangle 9"/>
+          <p:cNvPr id="5" name="Rounded Rectangle 4"/>
           <p:cNvSpPr/>
           <p:nvPr/>
         </p:nvSpPr>
         <p:spPr>
           <a:xfrm>
-            <a:off x="8961120" y="1417320"/>
-            <a:ext cx="2834640" cy="4480560"/>
+            <a:off x="9311335" y="1417320"/>
+            <a:ext cx="2514600" cy="4480560"/>
           </a:xfrm>
           <a:prstGeom prst="roundRect">
             <a:avLst>
@@ -15603,25 +15300,26 @@
           </a:fontRef>
         </p:style>
         <p:txBody>
-          <a:bodyPr rtlCol="0" anchor="ctr" wrap="square" lIns="182880" tIns="182880" rIns="137160"/>
+          <a:bodyPr rtlCol="0" anchor="ctr" wrap="square" lIns="164592" tIns="164592" rIns="109728"/>
           <a:lstStyle/>
           <a:p>
             <a:pPr algn="ctr">
               <a:spcAft>
-                <a:spcPts val="800"/>
+                <a:spcPts val="700"/>
               </a:spcAft>
             </a:pPr>
             <a:r>
-              <a:rPr b="1" sz="1400">
+              <a:rPr b="1" sz="1300">
                 <a:solidFill>
                   <a:srgbClr val="002856"/>
                 </a:solidFill>
                 <a:latin typeface="Arial"/>
               </a:rPr>
-              <a:t>Pilot Specifications</a:t>
-            </a:r>
-            <a:r>
-              <a:rPr b="1" sz="1200">
+              <a:t>Pilot
+Specifications</a:t>
+            </a:r>
+            <a:r>
+              <a:rPr b="1" sz="1100">
                 <a:solidFill>
                   <a:srgbClr val="FF8200"/>
                 </a:solidFill>
@@ -15630,7 +15328,7 @@
               <a:t>•  </a:t>
             </a:r>
             <a:r>
-              <a:rPr sz="1200">
+              <a:rPr sz="1100">
                 <a:solidFill>
                   <a:srgbClr val="404040"/>
                 </a:solidFill>
@@ -15642,11 +15340,11 @@
           <a:p>
             <a:pPr>
               <a:spcAft>
-                <a:spcPts val="800"/>
+                <a:spcPts val="700"/>
               </a:spcAft>
             </a:pPr>
             <a:r>
-              <a:rPr b="1" sz="1200">
+              <a:rPr b="1" sz="1100">
                 <a:solidFill>
                   <a:srgbClr val="FF8200"/>
                 </a:solidFill>
@@ -15655,7 +15353,7 @@
               <a:t>•  </a:t>
             </a:r>
             <a:r>
-              <a:rPr sz="1200">
+              <a:rPr sz="1100">
                 <a:solidFill>
                   <a:srgbClr val="404040"/>
                 </a:solidFill>
@@ -15667,11 +15365,11 @@
           <a:p>
             <a:pPr>
               <a:spcAft>
-                <a:spcPts val="800"/>
+                <a:spcPts val="700"/>
               </a:spcAft>
             </a:pPr>
             <a:r>
-              <a:rPr b="1" sz="1200">
+              <a:rPr b="1" sz="1100">
                 <a:solidFill>
                   <a:srgbClr val="FF8200"/>
                 </a:solidFill>
@@ -15680,7 +15378,7 @@
               <a:t>•  </a:t>
             </a:r>
             <a:r>
-              <a:rPr sz="1200">
+              <a:rPr sz="1100">
                 <a:solidFill>
                   <a:srgbClr val="404040"/>
                 </a:solidFill>
@@ -15692,11 +15390,11 @@
           <a:p>
             <a:pPr>
               <a:spcAft>
-                <a:spcPts val="800"/>
+                <a:spcPts val="700"/>
               </a:spcAft>
             </a:pPr>
             <a:r>
-              <a:rPr b="1" sz="1200">
+              <a:rPr b="1" sz="1100">
                 <a:solidFill>
                   <a:srgbClr val="FF8200"/>
                 </a:solidFill>
@@ -15705,7 +15403,7 @@
               <a:t>•  </a:t>
             </a:r>
             <a:r>
-              <a:rPr sz="1200">
+              <a:rPr sz="1100">
                 <a:solidFill>
                   <a:srgbClr val="404040"/>
                 </a:solidFill>
@@ -15717,11 +15415,11 @@
           <a:p>
             <a:pPr>
               <a:spcAft>
-                <a:spcPts val="800"/>
+                <a:spcPts val="700"/>
               </a:spcAft>
             </a:pPr>
             <a:r>
-              <a:rPr b="1" sz="1200">
+              <a:rPr b="1" sz="1100">
                 <a:solidFill>
                   <a:srgbClr val="FF8200"/>
                 </a:solidFill>
@@ -15730,7 +15428,7 @@
               <a:t>•  </a:t>
             </a:r>
             <a:r>
-              <a:rPr sz="1200">
+              <a:rPr sz="1100">
                 <a:solidFill>
                   <a:srgbClr val="404040"/>
                 </a:solidFill>
@@ -15743,14 +15441,14 @@
       </p:sp>
       <p:sp>
         <p:nvSpPr>
-          <p:cNvPr id="11" name="TextBox 10"/>
+          <p:cNvPr id="6" name="TextBox 5"/>
           <p:cNvSpPr txBox="1"/>
           <p:nvPr/>
         </p:nvSpPr>
         <p:spPr>
           <a:xfrm>
-            <a:off x="3566160" y="2423160"/>
-            <a:ext cx="5029200" cy="320040"/>
+            <a:off x="3200400" y="2468880"/>
+            <a:ext cx="5790895" cy="320040"/>
           </a:xfrm>
           <a:prstGeom prst="rect">
             <a:avLst/>
@@ -15772,6 +15470,310 @@
                 <a:latin typeface="Arial"/>
               </a:rPr>
               <a:t>THE PILOT FLOW</a:t>
+            </a:r>
+          </a:p>
+        </p:txBody>
+      </p:sp>
+      <p:sp>
+        <p:nvSpPr>
+          <p:cNvPr id="7" name="Chevron 6"/>
+          <p:cNvSpPr/>
+          <p:nvPr/>
+        </p:nvSpPr>
+        <p:spPr>
+          <a:xfrm>
+            <a:off x="3200400" y="2880360"/>
+            <a:ext cx="1319113" cy="960120"/>
+          </a:xfrm>
+          <a:prstGeom prst="chevron">
+            <a:avLst>
+              <a:gd name="adj" fmla="val 30000"/>
+            </a:avLst>
+          </a:prstGeom>
+          <a:solidFill>
+            <a:srgbClr val="002856"/>
+          </a:solidFill>
+          <a:ln w="19050">
+            <a:solidFill>
+              <a:srgbClr val="FFFFFF"/>
+            </a:solidFill>
+          </a:ln>
+        </p:spPr>
+        <p:style>
+          <a:lnRef idx="1">
+            <a:schemeClr val="accent1"/>
+          </a:lnRef>
+          <a:fillRef idx="3">
+            <a:schemeClr val="accent1"/>
+          </a:fillRef>
+          <a:effectRef idx="2">
+            <a:schemeClr val="accent1"/>
+          </a:effectRef>
+          <a:fontRef idx="minor">
+            <a:schemeClr val="lt1"/>
+          </a:fontRef>
+        </p:style>
+        <p:txBody>
+          <a:bodyPr rtlCol="0" anchor="ctr" wrap="square" lIns="45720" rIns="228600"/>
+          <a:lstStyle/>
+          <a:p>
+            <a:pPr algn="ctr"/>
+            <a:r>
+              <a:rPr b="1" sz="1050">
+                <a:solidFill>
+                  <a:srgbClr val="FFFFFF"/>
+                </a:solidFill>
+                <a:latin typeface="Arial"/>
+              </a:rPr>
+              <a:t>DTE Energy</a:t>
+            </a:r>
+          </a:p>
+          <a:p>
+            <a:pPr algn="ctr"/>
+            <a:r>
+              <a:rPr sz="800" i="1">
+                <a:solidFill>
+                  <a:srgbClr val="FFFFFF"/>
+                </a:solidFill>
+                <a:latin typeface="Arial"/>
+              </a:rPr>
+              <a:t>Owns Assets</a:t>
+            </a:r>
+          </a:p>
+        </p:txBody>
+      </p:sp>
+      <p:sp>
+        <p:nvSpPr>
+          <p:cNvPr id="8" name="Chevron 7"/>
+          <p:cNvSpPr/>
+          <p:nvPr/>
+        </p:nvSpPr>
+        <p:spPr>
+          <a:xfrm>
+            <a:off x="4318345" y="2880360"/>
+            <a:ext cx="1319113" cy="960120"/>
+          </a:xfrm>
+          <a:prstGeom prst="chevron">
+            <a:avLst>
+              <a:gd name="adj" fmla="val 30000"/>
+            </a:avLst>
+          </a:prstGeom>
+          <a:solidFill>
+            <a:srgbClr val="FF8200"/>
+          </a:solidFill>
+          <a:ln w="19050">
+            <a:solidFill>
+              <a:srgbClr val="FFFFFF"/>
+            </a:solidFill>
+          </a:ln>
+        </p:spPr>
+        <p:style>
+          <a:lnRef idx="1">
+            <a:schemeClr val="accent1"/>
+          </a:lnRef>
+          <a:fillRef idx="3">
+            <a:schemeClr val="accent1"/>
+          </a:fillRef>
+          <a:effectRef idx="2">
+            <a:schemeClr val="accent1"/>
+          </a:effectRef>
+          <a:fontRef idx="minor">
+            <a:schemeClr val="lt1"/>
+          </a:fontRef>
+        </p:style>
+        <p:txBody>
+          <a:bodyPr rtlCol="0" anchor="ctr" wrap="square" lIns="45720" rIns="228600"/>
+          <a:lstStyle/>
+          <a:p>
+            <a:pPr algn="ctr"/>
+            <a:r>
+              <a:rPr b="1" sz="1050">
+                <a:solidFill>
+                  <a:srgbClr val="FFFFFF"/>
+                </a:solidFill>
+                <a:latin typeface="Arial"/>
+              </a:rPr>
+              <a:t>APTIM</a:t>
+            </a:r>
+          </a:p>
+          <a:p>
+            <a:pPr algn="ctr"/>
+            <a:r>
+              <a:rPr sz="800" i="1">
+                <a:solidFill>
+                  <a:srgbClr val="FFFFFF"/>
+                </a:solidFill>
+                <a:latin typeface="Arial"/>
+              </a:rPr>
+              <a:t>Administers</a:t>
+            </a:r>
+          </a:p>
+        </p:txBody>
+      </p:sp>
+      <p:sp>
+        <p:nvSpPr>
+          <p:cNvPr id="9" name="Chevron 8"/>
+          <p:cNvSpPr/>
+          <p:nvPr/>
+        </p:nvSpPr>
+        <p:spPr>
+          <a:xfrm>
+            <a:off x="5436290" y="2880360"/>
+            <a:ext cx="1319113" cy="960120"/>
+          </a:xfrm>
+          <a:prstGeom prst="chevron">
+            <a:avLst>
+              <a:gd name="adj" fmla="val 30000"/>
+            </a:avLst>
+          </a:prstGeom>
+          <a:solidFill>
+            <a:srgbClr val="3D7CC9"/>
+          </a:solidFill>
+          <a:ln w="19050">
+            <a:solidFill>
+              <a:srgbClr val="FFFFFF"/>
+            </a:solidFill>
+          </a:ln>
+        </p:spPr>
+        <p:style>
+          <a:lnRef idx="1">
+            <a:schemeClr val="accent1"/>
+          </a:lnRef>
+          <a:fillRef idx="3">
+            <a:schemeClr val="accent1"/>
+          </a:fillRef>
+          <a:effectRef idx="2">
+            <a:schemeClr val="accent1"/>
+          </a:effectRef>
+          <a:fontRef idx="minor">
+            <a:schemeClr val="lt1"/>
+          </a:fontRef>
+        </p:style>
+        <p:txBody>
+          <a:bodyPr rtlCol="0" anchor="ctr" wrap="square" lIns="45720" rIns="228600"/>
+          <a:lstStyle/>
+          <a:p>
+            <a:pPr algn="ctr"/>
+            <a:r>
+              <a:rPr b="1" sz="1050">
+                <a:solidFill>
+                  <a:srgbClr val="FFFFFF"/>
+                </a:solidFill>
+                <a:latin typeface="Arial"/>
+              </a:rPr>
+              <a:t>Certified Installers</a:t>
+            </a:r>
+          </a:p>
+        </p:txBody>
+      </p:sp>
+      <p:sp>
+        <p:nvSpPr>
+          <p:cNvPr id="10" name="Chevron 9"/>
+          <p:cNvSpPr/>
+          <p:nvPr/>
+        </p:nvSpPr>
+        <p:spPr>
+          <a:xfrm>
+            <a:off x="6554235" y="2880360"/>
+            <a:ext cx="1319113" cy="960120"/>
+          </a:xfrm>
+          <a:prstGeom prst="chevron">
+            <a:avLst>
+              <a:gd name="adj" fmla="val 30000"/>
+            </a:avLst>
+          </a:prstGeom>
+          <a:solidFill>
+            <a:srgbClr val="00A19B"/>
+          </a:solidFill>
+          <a:ln w="19050">
+            <a:solidFill>
+              <a:srgbClr val="FFFFFF"/>
+            </a:solidFill>
+          </a:ln>
+        </p:spPr>
+        <p:style>
+          <a:lnRef idx="1">
+            <a:schemeClr val="accent1"/>
+          </a:lnRef>
+          <a:fillRef idx="3">
+            <a:schemeClr val="accent1"/>
+          </a:fillRef>
+          <a:effectRef idx="2">
+            <a:schemeClr val="accent1"/>
+          </a:effectRef>
+          <a:fontRef idx="minor">
+            <a:schemeClr val="lt1"/>
+          </a:fontRef>
+        </p:style>
+        <p:txBody>
+          <a:bodyPr rtlCol="0" anchor="ctr" wrap="square" lIns="45720" rIns="228600"/>
+          <a:lstStyle/>
+          <a:p>
+            <a:pPr algn="ctr"/>
+            <a:r>
+              <a:rPr b="1" sz="1050">
+                <a:solidFill>
+                  <a:srgbClr val="FFFFFF"/>
+                </a:solidFill>
+                <a:latin typeface="Arial"/>
+              </a:rPr>
+              <a:t>500 Homes</a:t>
+            </a:r>
+          </a:p>
+        </p:txBody>
+      </p:sp>
+      <p:sp>
+        <p:nvSpPr>
+          <p:cNvPr id="11" name="Chevron 10"/>
+          <p:cNvSpPr/>
+          <p:nvPr/>
+        </p:nvSpPr>
+        <p:spPr>
+          <a:xfrm>
+            <a:off x="7672180" y="2880360"/>
+            <a:ext cx="1319113" cy="960120"/>
+          </a:xfrm>
+          <a:prstGeom prst="chevron">
+            <a:avLst>
+              <a:gd name="adj" fmla="val 30000"/>
+            </a:avLst>
+          </a:prstGeom>
+          <a:solidFill>
+            <a:srgbClr val="A32036"/>
+          </a:solidFill>
+          <a:ln w="19050">
+            <a:solidFill>
+              <a:srgbClr val="FFFFFF"/>
+            </a:solidFill>
+          </a:ln>
+        </p:spPr>
+        <p:style>
+          <a:lnRef idx="1">
+            <a:schemeClr val="accent1"/>
+          </a:lnRef>
+          <a:fillRef idx="3">
+            <a:schemeClr val="accent1"/>
+          </a:fillRef>
+          <a:effectRef idx="2">
+            <a:schemeClr val="accent1"/>
+          </a:effectRef>
+          <a:fontRef idx="minor">
+            <a:schemeClr val="lt1"/>
+          </a:fontRef>
+        </p:style>
+        <p:txBody>
+          <a:bodyPr rtlCol="0" anchor="ctr" wrap="square" lIns="45720" rIns="228600"/>
+          <a:lstStyle/>
+          <a:p>
+            <a:pPr algn="ctr"/>
+            <a:r>
+              <a:rPr b="1" sz="1050">
+                <a:solidFill>
+                  <a:srgbClr val="FFFFFF"/>
+                </a:solidFill>
+                <a:latin typeface="Arial"/>
+              </a:rPr>
+              <a:t>3 MW Solar + 7.5 MWh</a:t>
             </a:r>
           </a:p>
         </p:txBody>
@@ -15993,7 +15995,7 @@
         <p:spPr>
           <a:xfrm>
             <a:off x="365760" y="1463040"/>
-            <a:ext cx="3657600" cy="3794760"/>
+            <a:ext cx="3637178" cy="3794760"/>
           </a:xfrm>
           <a:prstGeom prst="roundRect">
             <a:avLst>
@@ -16047,11 +16049,11 @@
         <p:spPr>
           <a:xfrm>
             <a:off x="365760" y="1463040"/>
-            <a:ext cx="3657600" cy="457200"/>
+            <a:ext cx="3637178" cy="502920"/>
           </a:xfrm>
           <a:prstGeom prst="roundRect">
             <a:avLst>
-              <a:gd name="adj" fmla="val 15000"/>
+              <a:gd name="adj" fmla="val 12000"/>
             </a:avLst>
           </a:prstGeom>
           <a:solidFill>
@@ -16100,8 +16102,8 @@
         </p:nvSpPr>
         <p:spPr>
           <a:xfrm>
-            <a:off x="502920" y="2057400"/>
-            <a:ext cx="3383280" cy="3063240"/>
+            <a:off x="548640" y="2148840"/>
+            <a:ext cx="3271418" cy="2926080"/>
           </a:xfrm>
           <a:prstGeom prst="rect">
             <a:avLst/>
@@ -16120,19 +16122,19 @@
               </a:spcAft>
             </a:pPr>
             <a:r>
-              <a:rPr b="1" sz="1600">
+              <a:rPr b="1" sz="1700">
                 <a:solidFill>
                   <a:srgbClr val="002856"/>
                 </a:solidFill>
                 <a:latin typeface="Arial"/>
               </a:rPr>
-              <a:t>500  </a:t>
+              <a:t>500</a:t>
             </a:r>
           </a:p>
           <a:p>
             <a:pPr>
               <a:spcAft>
-                <a:spcPts val="1000"/>
+                <a:spcPts val="900"/>
               </a:spcAft>
             </a:pPr>
             <a:r>
@@ -16152,19 +16154,19 @@
               </a:spcAft>
             </a:pPr>
             <a:r>
-              <a:rPr b="1" sz="1600">
+              <a:rPr b="1" sz="1700">
                 <a:solidFill>
                   <a:srgbClr val="002856"/>
                 </a:solidFill>
                 <a:latin typeface="Arial"/>
               </a:rPr>
-              <a:t>3 MW  </a:t>
+              <a:t>3 MW</a:t>
             </a:r>
           </a:p>
           <a:p>
             <a:pPr>
               <a:spcAft>
-                <a:spcPts val="1000"/>
+                <a:spcPts val="900"/>
               </a:spcAft>
             </a:pPr>
             <a:r>
@@ -16184,19 +16186,19 @@
               </a:spcAft>
             </a:pPr>
             <a:r>
-              <a:rPr b="1" sz="1600">
+              <a:rPr b="1" sz="1700">
                 <a:solidFill>
                   <a:srgbClr val="002856"/>
                 </a:solidFill>
                 <a:latin typeface="Arial"/>
               </a:rPr>
-              <a:t>7.5 MWh  </a:t>
+              <a:t>7.5 MWh</a:t>
             </a:r>
           </a:p>
           <a:p>
             <a:pPr>
               <a:spcAft>
-                <a:spcPts val="1000"/>
+                <a:spcPts val="900"/>
               </a:spcAft>
             </a:pPr>
             <a:r>
@@ -16216,19 +16218,19 @@
               </a:spcAft>
             </a:pPr>
             <a:r>
-              <a:rPr b="1" sz="1600">
+              <a:rPr b="1" sz="1700">
                 <a:solidFill>
                   <a:srgbClr val="002856"/>
                 </a:solidFill>
                 <a:latin typeface="Arial"/>
               </a:rPr>
-              <a:t>$34,500  </a:t>
+              <a:t>$34,500</a:t>
             </a:r>
           </a:p>
           <a:p>
             <a:pPr>
               <a:spcAft>
-                <a:spcPts val="1000"/>
+                <a:spcPts val="900"/>
               </a:spcAft>
             </a:pPr>
             <a:r>
@@ -16248,19 +16250,19 @@
               </a:spcAft>
             </a:pPr>
             <a:r>
-              <a:rPr b="1" sz="1600">
+              <a:rPr b="1" sz="1700">
                 <a:solidFill>
                   <a:srgbClr val="002856"/>
                 </a:solidFill>
                 <a:latin typeface="Arial"/>
               </a:rPr>
-              <a:t>$17.25M  </a:t>
+              <a:t>$17.25M</a:t>
             </a:r>
           </a:p>
           <a:p>
             <a:pPr>
               <a:spcAft>
-                <a:spcPts val="1000"/>
+                <a:spcPts val="900"/>
               </a:spcAft>
             </a:pPr>
             <a:r>
@@ -16283,8 +16285,8 @@
         </p:nvSpPr>
         <p:spPr>
           <a:xfrm>
-            <a:off x="4251960" y="1463040"/>
-            <a:ext cx="3657600" cy="3794760"/>
+            <a:off x="4277258" y="1463040"/>
+            <a:ext cx="3637178" cy="3794760"/>
           </a:xfrm>
           <a:prstGeom prst="roundRect">
             <a:avLst>
@@ -16337,12 +16339,12 @@
         </p:nvSpPr>
         <p:spPr>
           <a:xfrm>
-            <a:off x="4251960" y="1463040"/>
-            <a:ext cx="3657600" cy="457200"/>
+            <a:off x="4277258" y="1463040"/>
+            <a:ext cx="3637178" cy="502920"/>
           </a:xfrm>
           <a:prstGeom prst="roundRect">
             <a:avLst>
-              <a:gd name="adj" fmla="val 15000"/>
+              <a:gd name="adj" fmla="val 12000"/>
             </a:avLst>
           </a:prstGeom>
           <a:solidFill>
@@ -16391,8 +16393,8 @@
         </p:nvSpPr>
         <p:spPr>
           <a:xfrm>
-            <a:off x="4389120" y="2057400"/>
-            <a:ext cx="3383280" cy="3063240"/>
+            <a:off x="4460138" y="2148840"/>
+            <a:ext cx="3271418" cy="2926080"/>
           </a:xfrm>
           <a:prstGeom prst="rect">
             <a:avLst/>
@@ -16411,19 +16413,19 @@
               </a:spcAft>
             </a:pPr>
             <a:r>
-              <a:rPr b="1" sz="1600">
+              <a:rPr b="1" sz="1700">
                 <a:solidFill>
                   <a:srgbClr val="FF8200"/>
                 </a:solidFill>
                 <a:latin typeface="Arial"/>
               </a:rPr>
-              <a:t>$1.5M  </a:t>
+              <a:t>$1.5M</a:t>
             </a:r>
           </a:p>
           <a:p>
             <a:pPr>
               <a:spcAft>
-                <a:spcPts val="1000"/>
+                <a:spcPts val="900"/>
               </a:spcAft>
             </a:pPr>
             <a:r>
@@ -16443,19 +16445,19 @@
               </a:spcAft>
             </a:pPr>
             <a:r>
-              <a:rPr b="1" sz="1600">
+              <a:rPr b="1" sz="1700">
                 <a:solidFill>
                   <a:srgbClr val="FF8200"/>
                 </a:solidFill>
                 <a:latin typeface="Arial"/>
               </a:rPr>
-              <a:t>3 Years  </a:t>
+              <a:t>3 Years</a:t>
             </a:r>
           </a:p>
           <a:p>
             <a:pPr>
               <a:spcAft>
-                <a:spcPts val="1000"/>
+                <a:spcPts val="900"/>
               </a:spcAft>
             </a:pPr>
             <a:r>
@@ -16475,19 +16477,19 @@
               </a:spcAft>
             </a:pPr>
             <a:r>
-              <a:rPr b="1" sz="1600">
+              <a:rPr b="1" sz="1700">
                 <a:solidFill>
                   <a:srgbClr val="FF8200"/>
                 </a:solidFill>
                 <a:latin typeface="Arial"/>
               </a:rPr>
-              <a:t>$4.5M  </a:t>
+              <a:t>$4.5M</a:t>
             </a:r>
           </a:p>
           <a:p>
             <a:pPr>
               <a:spcAft>
-                <a:spcPts val="1000"/>
+                <a:spcPts val="900"/>
               </a:spcAft>
             </a:pPr>
             <a:r>
@@ -16510,8 +16512,8 @@
         </p:nvSpPr>
         <p:spPr>
           <a:xfrm>
-            <a:off x="8138160" y="1463040"/>
-            <a:ext cx="3657600" cy="3794760"/>
+            <a:off x="8188756" y="1463040"/>
+            <a:ext cx="3637178" cy="3794760"/>
           </a:xfrm>
           <a:prstGeom prst="roundRect">
             <a:avLst>
@@ -16564,12 +16566,12 @@
         </p:nvSpPr>
         <p:spPr>
           <a:xfrm>
-            <a:off x="8138160" y="1463040"/>
-            <a:ext cx="3657600" cy="457200"/>
+            <a:off x="8188756" y="1463040"/>
+            <a:ext cx="3637178" cy="502920"/>
           </a:xfrm>
           <a:prstGeom prst="roundRect">
             <a:avLst>
-              <a:gd name="adj" fmla="val 15000"/>
+              <a:gd name="adj" fmla="val 12000"/>
             </a:avLst>
           </a:prstGeom>
           <a:solidFill>
@@ -16618,8 +16620,8 @@
         </p:nvSpPr>
         <p:spPr>
           <a:xfrm>
-            <a:off x="8275320" y="2103120"/>
-            <a:ext cx="3383280" cy="3017520"/>
+            <a:off x="8371636" y="2240280"/>
+            <a:ext cx="3271418" cy="2834640"/>
           </a:xfrm>
           <a:prstGeom prst="rect">
             <a:avLst/>
@@ -16638,7 +16640,7 @@
               </a:spcAft>
             </a:pPr>
             <a:r>
-              <a:rPr b="1" sz="1400">
+              <a:rPr b="1" sz="1300">
                 <a:solidFill>
                   <a:srgbClr val="00A19B"/>
                 </a:solidFill>
@@ -16647,7 +16649,7 @@
               <a:t>✓  </a:t>
             </a:r>
             <a:r>
-              <a:rPr sz="1400">
+              <a:rPr sz="1300">
                 <a:solidFill>
                   <a:srgbClr val="404040"/>
                 </a:solidFill>
@@ -16663,7 +16665,7 @@
               </a:spcAft>
             </a:pPr>
             <a:r>
-              <a:rPr b="1" sz="1400">
+              <a:rPr b="1" sz="1300">
                 <a:solidFill>
                   <a:srgbClr val="00A19B"/>
                 </a:solidFill>
@@ -16672,7 +16674,7 @@
               <a:t>✓  </a:t>
             </a:r>
             <a:r>
-              <a:rPr sz="1400">
+              <a:rPr sz="1300">
                 <a:solidFill>
                   <a:srgbClr val="404040"/>
                 </a:solidFill>
@@ -16688,7 +16690,7 @@
               </a:spcAft>
             </a:pPr>
             <a:r>
-              <a:rPr b="1" sz="1400">
+              <a:rPr b="1" sz="1300">
                 <a:solidFill>
                   <a:srgbClr val="00A19B"/>
                 </a:solidFill>
@@ -16697,7 +16699,7 @@
               <a:t>✓  </a:t>
             </a:r>
             <a:r>
-              <a:rPr sz="1400">
+              <a:rPr sz="1300">
                 <a:solidFill>
                   <a:srgbClr val="404040"/>
                 </a:solidFill>
@@ -16713,7 +16715,7 @@
               </a:spcAft>
             </a:pPr>
             <a:r>
-              <a:rPr b="1" sz="1400">
+              <a:rPr b="1" sz="1300">
                 <a:solidFill>
                   <a:srgbClr val="00A19B"/>
                 </a:solidFill>
@@ -16722,7 +16724,7 @@
               <a:t>✓  </a:t>
             </a:r>
             <a:r>
-              <a:rPr sz="1400">
+              <a:rPr sz="1300">
                 <a:solidFill>
                   <a:srgbClr val="404040"/>
                 </a:solidFill>

</xml_diff>